<commit_message>
Reescritura de documentos: mas contenido y lenguaje natural - Memoria, informe tecnico e informe ejecutivo ampliados y en voz de autor - Textos de la presentacion humanizados (maqueta intacta) - Retirados del repo los PDF desfasados (regenerar desde los .docx actualizados)
</commit_message>
<xml_diff>
--- a/presentacion/JAMSEC_Presentacion.pptx
+++ b/presentacion/JAMSEC_Presentacion.pptx
@@ -3435,7 +3435,7 @@
                 <a:ea typeface="Calibri" pitchFamily="34" charset="-122"/>
                 <a:cs typeface="Calibri" pitchFamily="34" charset="-120"/>
               </a:rPr>
-              <a:t>Todo reproducible: configuración como código (cloud-init + scripts) versionada en Git.</a:t>
+              <a:t>Casi todo quedó como código (cloud-init + scripts) guardado en Git, así que se puede volver a montar entero.</a:t>
             </a:r>
             <a:endParaRPr lang="en-US" sz="1250" dirty="0"/>
           </a:p>
@@ -5132,7 +5132,7 @@
                 <a:ea typeface="Calibri" pitchFamily="34" charset="-122"/>
                 <a:cs typeface="Calibri" pitchFamily="34" charset="-120"/>
               </a:rPr>
-              <a:t>Compromiso total del cliente: desde Internet hasta el robo de datos personales y financieros (NIF, IBAN, nóminas) almacenados en la red interna. El SIEM detectó el escaneo, la fuerza bruta y los accesos.</a:t>
+              <a:t>Resumiendo: entré desde internet, sin nada, y acabé sacando datos personales y financieros (NIF, IBAN, nóminas) de la red interna. Y mientras tanto el SIEM iba detectando el escaneo, la fuerza bruta y los accesos.</a:t>
             </a:r>
             <a:endParaRPr lang="en-US" sz="1400" dirty="0"/>
           </a:p>
@@ -7402,7 +7402,7 @@
                 <a:ea typeface="Calibri" pitchFamily="34" charset="-122"/>
                 <a:cs typeface="Calibri" pitchFamily="34" charset="-120"/>
               </a:rPr>
-              <a:t>JAMSEC es una empresa de ciberseguridad que despliega su propia infraestructura, monitoriza la de sus clientes y audita su seguridad. El proyecto recrea ese ciclo completo de extremo a extremo sobre un clúster de virtualización.</a:t>
+              <a:t>JAMSEC es la empresa de ciberseguridad que represento en el proyecto. Monta su propia infraestructura, vigila la de sus clientes y, cuando se lo piden, los audita. Lo he montado todo sobre un clúster de virtualización real, con máquinas y servicios de verdad, no simulado.</a:t>
             </a:r>
             <a:endParaRPr lang="en-US" sz="1600" dirty="0"/>
           </a:p>
@@ -7534,7 +7534,7 @@
                 <a:ea typeface="Calibri" pitchFamily="34" charset="-122"/>
                 <a:cs typeface="Calibri" pitchFamily="34" charset="-120"/>
               </a:rPr>
-              <a:t>Empresa de ciberseguridad. Infraestructura propia + SOC (centro de operaciones).</a:t>
+              <a:t>La empresa de ciberseguridad: su propia infraestructura y un SOC desde el que vigila y ataca.</a:t>
             </a:r>
             <a:endParaRPr lang="en-US" sz="1300" dirty="0"/>
           </a:p>
@@ -7666,7 +7666,7 @@
                 <a:ea typeface="Calibri" pitchFamily="34" charset="-122"/>
                 <a:cs typeface="Calibri" pitchFamily="34" charset="-120"/>
               </a:rPr>
-              <a:t>Cliente / víctima. Infraestructura objetivo de la auditoría de intrusión.</a:t>
+              <a:t>El cliente, o más bien la víctima: la gestoría a la que acabo auditando.</a:t>
             </a:r>
             <a:endParaRPr lang="en-US" sz="1300" dirty="0"/>
           </a:p>
@@ -7798,7 +7798,7 @@
                 <a:ea typeface="Calibri" pitchFamily="34" charset="-122"/>
                 <a:cs typeface="Calibri" pitchFamily="34" charset="-120"/>
               </a:rPr>
-              <a:t>Clúster Proxmox VE de 3 nodos; dos infraestructuras separadas físicamente.</a:t>
+              <a:t>Un clúster Proxmox de 3 nodos. Cada empresa va en un nodo distinto, separadas de verdad.</a:t>
             </a:r>
             <a:endParaRPr lang="en-US" sz="1300" dirty="0"/>
           </a:p>
@@ -8778,7 +8778,7 @@
                 <a:ea typeface="Calibri" pitchFamily="34" charset="-122"/>
                 <a:cs typeface="Calibri" pitchFamily="34" charset="-120"/>
               </a:rPr>
-              <a:t>Política: la DMZ y los servicios internos están aislados entre sí y del SOC; salida a Internet controlada y publicación de la web por DNAT. Verificado: la DMZ NO alcanza la red interna.</a:t>
+              <a:t>La idea es sencilla: si alguien reventara la web de la DMZ, no debería poder llegar ni a los ficheros internos ni al SOC. Lo comprobé y, efectivamente, desde la DMZ no se llega a la red interna.</a:t>
             </a:r>
             <a:endParaRPr lang="en-US" sz="1300" dirty="0"/>
           </a:p>
@@ -9780,7 +9780,7 @@
                 <a:ea typeface="Calibri" pitchFamily="34" charset="-122"/>
                 <a:cs typeface="Calibri" pitchFamily="34" charset="-120"/>
               </a:rPr>
-              <a:t>Las vulnerabilidades son intencionadas y representan malas prácticas reales en pymes.</a:t>
+              <a:t>Los fallos los puse a propósito: son los típicos que te acabas encontrando en una pyme de verdad.</a:t>
             </a:r>
             <a:endParaRPr lang="en-US" sz="1250" dirty="0"/>
           </a:p>
@@ -9890,7 +9890,7 @@
                 <a:ea typeface="Calibri" pitchFamily="34" charset="-122"/>
                 <a:cs typeface="Calibri" pitchFamily="34" charset="-120"/>
               </a:rPr>
-              <a:t>Wazuh (SIEM + HIDS) en el SOC y Suricata (IDS de red) en los dos cortafuegos vigilan ambas infraestructuras de forma centralizada.</a:t>
+              <a:t>Para vigilar las dos infraestructuras usé Wazuh como SIEM en el SOC y Suricata como IDS de red en los dos cortafuegos. La gracia es que todo se ve desde un único panel.</a:t>
             </a:r>
             <a:endParaRPr lang="en-US" sz="1500" dirty="0"/>
           </a:p>

</xml_diff>